<commit_message>
added logo and deployed .tech
</commit_message>
<xml_diff>
--- a/Inoki Labs Pitch Deck.pptx
+++ b/Inoki Labs Pitch Deck.pptx
@@ -2160,7 +2160,7 @@
                 <a:ea typeface="Geist" pitchFamily="34" charset="-122"/>
                 <a:cs typeface="Geist" pitchFamily="34" charset="-120"/>
               </a:rPr>
-              <a:t>Vihan Aggarwal · Subhiksha Stephan</a:t>
+              <a:t>Vihan Aggarwal · Subhi Stephan</a:t>
             </a:r>
             <a:endParaRPr lang="en-US" sz="1300" dirty="0"/>
           </a:p>
@@ -9852,7 +9852,7 @@
                 <a:ea typeface="Geist Mono" pitchFamily="34" charset="-122"/>
                 <a:cs typeface="Geist Mono" pitchFamily="34" charset="-120"/>
               </a:rPr>
-              <a:t>CO-FOUNDER · CEO AND CTO</a:t>
+              <a:t>CO-FOUNDER · CEO AND CGO</a:t>
             </a:r>
             <a:endParaRPr lang="en-US" sz="1100" dirty="0"/>
           </a:p>
@@ -10048,7 +10048,7 @@
                 <a:ea typeface="Geist" pitchFamily="34" charset="-122"/>
                 <a:cs typeface="Geist" pitchFamily="34" charset="-120"/>
               </a:rPr>
-              <a:t>Subhiksha Stephan</a:t>
+              <a:t>Subhi Stephan</a:t>
             </a:r>
             <a:endParaRPr lang="en-US" sz="2600" dirty="0"/>
           </a:p>
@@ -10087,7 +10087,7 @@
                 <a:ea typeface="Geist Mono" pitchFamily="34" charset="-122"/>
                 <a:cs typeface="Geist Mono" pitchFamily="34" charset="-120"/>
               </a:rPr>
-              <a:t>CO-FOUNDER · CGO AND CMO</a:t>
+              <a:t>CO-FOUNDER · CTO AND CMO</a:t>
             </a:r>
             <a:endParaRPr lang="en-US" sz="1100" dirty="0"/>
           </a:p>

</xml_diff>